<commit_message>
chore: update project files
</commit_message>
<xml_diff>
--- a/iuh/môn/hk1-4/quản trị và bảo trì hệ thống/lab/bainhom/Bao_cao_Active_Directory.pptx
+++ b/iuh/môn/hk1-4/quản trị và bảo trì hệ thống/lab/bainhom/Bao_cao_Active_Directory.pptx
@@ -6264,7 +6264,7 @@
         <p:spPr>
           <a:xfrm>
             <a:off x="731520" y="4956048"/>
-            <a:ext cx="10728655" cy="1280160"/>
+            <a:ext cx="10728655" cy="1353312"/>
           </a:xfrm>
           <a:prstGeom prst="roundRect">
             <a:avLst/>
@@ -6272,7 +6272,7 @@
           <a:solidFill>
             <a:srgbClr val="EFF6FF"/>
           </a:solidFill>
-          <a:ln>
+          <a:ln w="12700">
             <a:solidFill>
               <a:srgbClr val="BAE6FD"/>
             </a:solidFill>
@@ -6293,11 +6293,263 @@
           </a:fontRef>
         </p:style>
         <p:txBody>
-          <a:bodyPr rtlCol="0" anchor="ctr" wrap="square" tIns="91440" bIns="91440"/>
+          <a:bodyPr rtlCol="0" anchor="ctr"/>
+          <a:lstStyle/>
+          <a:p>
+            <a:pPr algn="ctr"/>
+          </a:p>
+        </p:txBody>
+      </p:sp>
+      <p:sp>
+        <p:nvSpPr>
+          <p:cNvPr id="18" name="Rounded Rectangle 17"/>
+          <p:cNvSpPr/>
+          <p:nvPr/>
+        </p:nvSpPr>
+        <p:spPr>
+          <a:xfrm>
+            <a:off x="1005840" y="5074920"/>
+            <a:ext cx="3291840" cy="658368"/>
+          </a:xfrm>
+          <a:prstGeom prst="roundRect">
+            <a:avLst/>
+          </a:prstGeom>
+          <a:solidFill>
+            <a:srgbClr val="003366"/>
+          </a:solidFill>
+          <a:ln>
+            <a:noFill/>
+          </a:ln>
+        </p:spPr>
+        <p:style>
+          <a:lnRef idx="1">
+            <a:schemeClr val="accent1"/>
+          </a:lnRef>
+          <a:fillRef idx="3">
+            <a:schemeClr val="accent1"/>
+          </a:fillRef>
+          <a:effectRef idx="2">
+            <a:schemeClr val="accent1"/>
+          </a:effectRef>
+          <a:fontRef idx="minor">
+            <a:schemeClr val="lt1"/>
+          </a:fontRef>
+        </p:style>
+        <p:txBody>
+          <a:bodyPr rtlCol="0" anchor="ctr"/>
           <a:lstStyle/>
           <a:p>
             <a:pPr algn="ctr">
-              <a:defRPr sz="1000" b="1">
+              <a:defRPr sz="850" b="1">
+                <a:solidFill>
+                  <a:srgbClr val="FFFFFF"/>
+                </a:solidFill>
+                <a:latin typeface="Segoe UI"/>
+              </a:defRPr>
+            </a:pPr>
+            <a:r>
+              <a:t>HỘI SỞ CHÍNH (HEADQUARTERS)</a:t>
+            </a:r>
+            <a:br/>
+            <a:r>
+              <a:t>Writable DC (Đọc/Ghi) • CSDL ntds.dit đầy đủ</a:t>
+            </a:r>
+          </a:p>
+        </p:txBody>
+      </p:sp>
+      <p:sp>
+        <p:nvSpPr>
+          <p:cNvPr id="19" name="Right Arrow 18"/>
+          <p:cNvSpPr/>
+          <p:nvPr/>
+        </p:nvSpPr>
+        <p:spPr>
+          <a:xfrm>
+            <a:off x="4434840" y="5230368"/>
+            <a:ext cx="1371600" cy="347472"/>
+          </a:xfrm>
+          <a:prstGeom prst="rightArrow">
+            <a:avLst/>
+          </a:prstGeom>
+          <a:solidFill>
+            <a:srgbClr val="0D9488"/>
+          </a:solidFill>
+          <a:ln>
+            <a:noFill/>
+          </a:ln>
+        </p:spPr>
+        <p:style>
+          <a:lnRef idx="1">
+            <a:schemeClr val="accent1"/>
+          </a:lnRef>
+          <a:fillRef idx="3">
+            <a:schemeClr val="accent1"/>
+          </a:fillRef>
+          <a:effectRef idx="2">
+            <a:schemeClr val="accent1"/>
+          </a:effectRef>
+          <a:fontRef idx="minor">
+            <a:schemeClr val="lt1"/>
+          </a:fontRef>
+        </p:style>
+        <p:txBody>
+          <a:bodyPr rtlCol="0" anchor="ctr"/>
+          <a:lstStyle/>
+          <a:p>
+            <a:pPr algn="ctr">
+              <a:defRPr sz="800" b="1">
+                <a:solidFill>
+                  <a:srgbClr val="FFFFFF"/>
+                </a:solidFill>
+                <a:latin typeface="Segoe UI"/>
+              </a:defRPr>
+            </a:pPr>
+            <a:r>
+              <a:t>VPN (1 chiều)</a:t>
+            </a:r>
+          </a:p>
+        </p:txBody>
+      </p:sp>
+      <p:sp>
+        <p:nvSpPr>
+          <p:cNvPr id="20" name="Rounded Rectangle 19"/>
+          <p:cNvSpPr/>
+          <p:nvPr/>
+        </p:nvSpPr>
+        <p:spPr>
+          <a:xfrm>
+            <a:off x="5943600" y="5074920"/>
+            <a:ext cx="3291840" cy="658368"/>
+          </a:xfrm>
+          <a:prstGeom prst="roundRect">
+            <a:avLst/>
+          </a:prstGeom>
+          <a:solidFill>
+            <a:srgbClr val="16A34A"/>
+          </a:solidFill>
+          <a:ln>
+            <a:noFill/>
+          </a:ln>
+        </p:spPr>
+        <p:style>
+          <a:lnRef idx="1">
+            <a:schemeClr val="accent1"/>
+          </a:lnRef>
+          <a:fillRef idx="3">
+            <a:schemeClr val="accent1"/>
+          </a:fillRef>
+          <a:effectRef idx="2">
+            <a:schemeClr val="accent1"/>
+          </a:effectRef>
+          <a:fontRef idx="minor">
+            <a:schemeClr val="lt1"/>
+          </a:fontRef>
+        </p:style>
+        <p:txBody>
+          <a:bodyPr rtlCol="0" anchor="ctr"/>
+          <a:lstStyle/>
+          <a:p>
+            <a:pPr algn="ctr">
+              <a:defRPr sz="850" b="1">
+                <a:solidFill>
+                  <a:srgbClr val="FFFFFF"/>
+                </a:solidFill>
+                <a:latin typeface="Segoe UI"/>
+              </a:defRPr>
+            </a:pPr>
+            <a:r>
+              <a:t>VĂN PHÒNG CHI NHÁNH (BRANCH OFFICE)</a:t>
+            </a:r>
+            <a:br/>
+            <a:r>
+              <a:t>RODC (Chỉ đọc) • Cache Password cục bộ qua PRP</a:t>
+            </a:r>
+          </a:p>
+        </p:txBody>
+      </p:sp>
+      <p:sp>
+        <p:nvSpPr>
+          <p:cNvPr id="21" name="Rounded Rectangle 20"/>
+          <p:cNvSpPr/>
+          <p:nvPr/>
+        </p:nvSpPr>
+        <p:spPr>
+          <a:xfrm>
+            <a:off x="9418320" y="5074920"/>
+            <a:ext cx="1737360" cy="658368"/>
+          </a:xfrm>
+          <a:prstGeom prst="roundRect">
+            <a:avLst/>
+          </a:prstGeom>
+          <a:solidFill>
+            <a:srgbClr val="FFFFFF"/>
+          </a:solidFill>
+          <a:ln w="19050">
+            <a:solidFill>
+              <a:srgbClr val="16A34A"/>
+            </a:solidFill>
+          </a:ln>
+        </p:spPr>
+        <p:style>
+          <a:lnRef idx="1">
+            <a:schemeClr val="accent1"/>
+          </a:lnRef>
+          <a:fillRef idx="3">
+            <a:schemeClr val="accent1"/>
+          </a:fillRef>
+          <a:effectRef idx="2">
+            <a:schemeClr val="accent1"/>
+          </a:effectRef>
+          <a:fontRef idx="minor">
+            <a:schemeClr val="lt1"/>
+          </a:fontRef>
+        </p:style>
+        <p:txBody>
+          <a:bodyPr rtlCol="0" anchor="ctr"/>
+          <a:lstStyle/>
+          <a:p>
+            <a:pPr algn="ctr">
+              <a:defRPr sz="800" b="1">
+                <a:solidFill>
+                  <a:srgbClr val="16A34A"/>
+                </a:solidFill>
+                <a:latin typeface="Segoe UI"/>
+              </a:defRPr>
+            </a:pPr>
+            <a:r>
+              <a:t>Client Chi Nhánh</a:t>
+            </a:r>
+            <a:br/>
+            <a:r>
+              <a:t>(Xác thực tức thì)</a:t>
+            </a:r>
+          </a:p>
+        </p:txBody>
+      </p:sp>
+      <p:sp>
+        <p:nvSpPr>
+          <p:cNvPr id="22" name="TextBox 21"/>
+          <p:cNvSpPr txBox="1"/>
+          <p:nvPr/>
+        </p:nvSpPr>
+        <p:spPr>
+          <a:xfrm>
+            <a:off x="914400" y="5833872"/>
+            <a:ext cx="10332720" cy="384048"/>
+          </a:xfrm>
+          <a:prstGeom prst="rect">
+            <a:avLst/>
+          </a:prstGeom>
+          <a:noFill/>
+        </p:spPr>
+        <p:txBody>
+          <a:bodyPr wrap="square">
+            <a:spAutoFit/>
+          </a:bodyPr>
+          <a:lstStyle/>
+          <a:p>
+            <a:pPr algn="ctr">
+              <a:defRPr sz="850" b="1">
                 <a:solidFill>
                   <a:srgbClr val="003366"/>
                 </a:solidFill>
@@ -6305,27 +6557,7 @@
               </a:defRPr>
             </a:pPr>
             <a:r>
-              <a:t>[MÔ HÌNH BẢO MẬT THỰC TẾ]:</a:t>
-            </a:r>
-          </a:p>
-          <a:p>
-            <a:pPr>
-              <a:spcBef>
-                <a:spcPts val="300"/>
-              </a:spcBef>
-              <a:defRPr sz="900">
-                <a:solidFill>
-                  <a:srgbClr val="1E293B"/>
-                </a:solidFill>
-                <a:latin typeface="Segoe UI"/>
-              </a:defRPr>
-            </a:pPr>
-            <a:r>
-              <a:t>• HỘI SỞ CHÍNH: Cặp Writable DC (đọc/ghi) trong Datacenter bảo mật cao, kết nối cáp quang Gigabit, nắm giữ toàn bộ 5 vai trò FSMO.</a:t>
-            </a:r>
-            <a:br/>
-            <a:r>
-              <a:t>• CHI NHÁNH: 1 máy chủ cài RODC kết nối về Hội sở qua VPN/WAN. Nhân viên chi nhánh xác thực tức thì qua Cache PRP; khi đứt mạng WAN vẫn làm việc bình thường!</a:t>
+              <a:t>[LỢI ÍCH SỐNG CÒN]: Khi đứt cáp quang WAN, Client chi nhánh vẫn đăng nhập bình thường bằng vé trong Cache PRP! Nếu máy chủ RODC bị đánh cắp, mật khẩu Admin không bao giờ bị lộ!</a:t>
             </a:r>
           </a:p>
         </p:txBody>
@@ -8006,8 +8238,8 @@
         </p:nvSpPr>
         <p:spPr>
           <a:xfrm>
-            <a:off x="1005840" y="1737360"/>
-            <a:ext cx="3291840" cy="1783080"/>
+            <a:off x="1005840" y="1719072"/>
+            <a:ext cx="3291840" cy="1810512"/>
           </a:xfrm>
           <a:prstGeom prst="roundRect">
             <a:avLst/>
@@ -8051,7 +8283,7 @@
         </p:nvSpPr>
         <p:spPr>
           <a:xfrm>
-            <a:off x="1005840" y="1737360"/>
+            <a:off x="1005840" y="1719072"/>
             <a:ext cx="3291840" cy="347472"/>
           </a:xfrm>
           <a:prstGeom prst="roundRect">
@@ -8104,8 +8336,8 @@
         </p:nvSpPr>
         <p:spPr>
           <a:xfrm>
-            <a:off x="1097280" y="2121408"/>
-            <a:ext cx="3108960" cy="1325880"/>
+            <a:off x="1097280" y="2084831"/>
+            <a:ext cx="3108960" cy="1051560"/>
           </a:xfrm>
           <a:prstGeom prst="rect">
             <a:avLst/>
@@ -8141,23 +8373,74 @@
             <a:r>
               <a:t>• Roles: AD DS, DNS Server, GC, 5 FSMO</a:t>
             </a:r>
-            <a:br/>
-            <a:r>
-              <a:t>• Miền quản trị: nhom1.vn</a:t>
-            </a:r>
-          </a:p>
-        </p:txBody>
-      </p:sp>
-      <p:sp>
-        <p:nvSpPr>
-          <p:cNvPr id="12" name="Hexagon 11"/>
+          </a:p>
+        </p:txBody>
+      </p:sp>
+      <p:sp>
+        <p:nvSpPr>
+          <p:cNvPr id="12" name="Can 11"/>
           <p:cNvSpPr/>
           <p:nvPr/>
         </p:nvSpPr>
         <p:spPr>
           <a:xfrm>
-            <a:off x="4754880" y="1965960"/>
-            <a:ext cx="2651760" cy="1325880"/>
+            <a:off x="1188720" y="3127248"/>
+            <a:ext cx="2926080" cy="347472"/>
+          </a:xfrm>
+          <a:prstGeom prst="can">
+            <a:avLst/>
+          </a:prstGeom>
+          <a:solidFill>
+            <a:srgbClr val="ECFEFF"/>
+          </a:solidFill>
+          <a:ln>
+            <a:solidFill>
+              <a:srgbClr val="003366"/>
+            </a:solidFill>
+          </a:ln>
+        </p:spPr>
+        <p:style>
+          <a:lnRef idx="1">
+            <a:schemeClr val="accent1"/>
+          </a:lnRef>
+          <a:fillRef idx="3">
+            <a:schemeClr val="accent1"/>
+          </a:fillRef>
+          <a:effectRef idx="2">
+            <a:schemeClr val="accent1"/>
+          </a:effectRef>
+          <a:fontRef idx="minor">
+            <a:schemeClr val="lt1"/>
+          </a:fontRef>
+        </p:style>
+        <p:txBody>
+          <a:bodyPr rtlCol="0" anchor="ctr"/>
+          <a:lstStyle/>
+          <a:p>
+            <a:pPr algn="ctr">
+              <a:defRPr sz="800" b="1">
+                <a:solidFill>
+                  <a:srgbClr val="003366"/>
+                </a:solidFill>
+                <a:latin typeface="Segoe UI"/>
+              </a:defRPr>
+            </a:pPr>
+            <a:r>
+              <a:t>ntds.dit (CSDL Miền nhom1.vn)</a:t>
+            </a:r>
+          </a:p>
+        </p:txBody>
+      </p:sp>
+      <p:sp>
+        <p:nvSpPr>
+          <p:cNvPr id="13" name="Hexagon 12"/>
+          <p:cNvSpPr/>
+          <p:nvPr/>
+        </p:nvSpPr>
+        <p:spPr>
+          <a:xfrm>
+            <a:off x="4709160" y="1920240"/>
+            <a:ext cx="2743200" cy="1371600"/>
           </a:xfrm>
           <a:prstGeom prst="hexagon">
             <a:avLst/>
@@ -8188,7 +8471,7 @@
           <a:lstStyle/>
           <a:p>
             <a:pPr algn="ctr">
-              <a:defRPr sz="900" b="1">
+              <a:defRPr sz="850" b="1">
                 <a:solidFill>
                   <a:srgbClr val="FFFFFF"/>
                 </a:solidFill>
@@ -8206,19 +8489,23 @@
             <a:r>
               <a:t>Dải IP: 192.168.11.0/24</a:t>
             </a:r>
-          </a:p>
-        </p:txBody>
-      </p:sp>
-      <p:sp>
-        <p:nvSpPr>
-          <p:cNvPr id="13" name="Rounded Rectangle 12"/>
+            <a:br/>
+            <a:r>
+              <a:t>Cách ly an toàn với mạng ngoài</a:t>
+            </a:r>
+          </a:p>
+        </p:txBody>
+      </p:sp>
+      <p:sp>
+        <p:nvSpPr>
+          <p:cNvPr id="14" name="Rounded Rectangle 13"/>
           <p:cNvSpPr/>
           <p:nvPr/>
         </p:nvSpPr>
         <p:spPr>
           <a:xfrm>
-            <a:off x="7863840" y="1737360"/>
-            <a:ext cx="3291840" cy="1783080"/>
+            <a:off x="7863840" y="1719072"/>
+            <a:ext cx="3291840" cy="1810512"/>
           </a:xfrm>
           <a:prstGeom prst="roundRect">
             <a:avLst/>
@@ -8256,13 +8543,13 @@
       </p:sp>
       <p:sp>
         <p:nvSpPr>
-          <p:cNvPr id="14" name="Rounded Rectangle 13"/>
+          <p:cNvPr id="15" name="Rounded Rectangle 14"/>
           <p:cNvSpPr/>
           <p:nvPr/>
         </p:nvSpPr>
         <p:spPr>
           <a:xfrm>
-            <a:off x="7863840" y="1737360"/>
+            <a:off x="7863840" y="1719072"/>
             <a:ext cx="3291840" cy="347472"/>
           </a:xfrm>
           <a:prstGeom prst="roundRect">
@@ -8309,14 +8596,14 @@
       </p:sp>
       <p:sp>
         <p:nvSpPr>
-          <p:cNvPr id="15" name="TextBox 14"/>
+          <p:cNvPr id="16" name="TextBox 15"/>
           <p:cNvSpPr txBox="1"/>
           <p:nvPr/>
         </p:nvSpPr>
         <p:spPr>
           <a:xfrm>
-            <a:off x="7955279" y="2121408"/>
-            <a:ext cx="3108960" cy="1325880"/>
+            <a:off x="7955279" y="2084831"/>
+            <a:ext cx="3108960" cy="1051560"/>
           </a:xfrm>
           <a:prstGeom prst="rect">
             <a:avLst/>
@@ -8352,23 +8639,74 @@
             <a:r>
               <a:t>• Trạng thái: Đã Join Domain nhom1.vn</a:t>
             </a:r>
-            <a:br/>
-            <a:r>
-              <a:t>• Đăng nhập tài khoản: nhom1\sv1</a:t>
-            </a:r>
-          </a:p>
-        </p:txBody>
-      </p:sp>
-      <p:sp>
-        <p:nvSpPr>
-          <p:cNvPr id="16" name="Left-Right Arrow 15"/>
+          </a:p>
+        </p:txBody>
+      </p:sp>
+      <p:sp>
+        <p:nvSpPr>
+          <p:cNvPr id="17" name="Rounded Rectangle 16"/>
           <p:cNvSpPr/>
           <p:nvPr/>
         </p:nvSpPr>
         <p:spPr>
           <a:xfrm>
-            <a:off x="4315968" y="2487168"/>
-            <a:ext cx="411480" cy="274320"/>
+            <a:off x="8046720" y="3127248"/>
+            <a:ext cx="2926080" cy="347472"/>
+          </a:xfrm>
+          <a:prstGeom prst="roundRect">
+            <a:avLst/>
+          </a:prstGeom>
+          <a:solidFill>
+            <a:srgbClr val="F0FDF4"/>
+          </a:solidFill>
+          <a:ln>
+            <a:solidFill>
+              <a:srgbClr val="16A34A"/>
+            </a:solidFill>
+          </a:ln>
+        </p:spPr>
+        <p:style>
+          <a:lnRef idx="1">
+            <a:schemeClr val="accent1"/>
+          </a:lnRef>
+          <a:fillRef idx="3">
+            <a:schemeClr val="accent1"/>
+          </a:fillRef>
+          <a:effectRef idx="2">
+            <a:schemeClr val="accent1"/>
+          </a:effectRef>
+          <a:fontRef idx="minor">
+            <a:schemeClr val="lt1"/>
+          </a:fontRef>
+        </p:style>
+        <p:txBody>
+          <a:bodyPr rtlCol="0" anchor="ctr"/>
+          <a:lstStyle/>
+          <a:p>
+            <a:pPr algn="ctr">
+              <a:defRPr sz="800" b="1">
+                <a:solidFill>
+                  <a:srgbClr val="16A34A"/>
+                </a:solidFill>
+                <a:latin typeface="Segoe UI"/>
+              </a:defRPr>
+            </a:pPr>
+            <a:r>
+              <a:t>[✓] Đăng nhập tài khoản: nhom1\sv1</a:t>
+            </a:r>
+          </a:p>
+        </p:txBody>
+      </p:sp>
+      <p:sp>
+        <p:nvSpPr>
+          <p:cNvPr id="18" name="Left-Right Arrow 17"/>
+          <p:cNvSpPr/>
+          <p:nvPr/>
+        </p:nvSpPr>
+        <p:spPr>
+          <a:xfrm>
+            <a:off x="4315968" y="2423160"/>
+            <a:ext cx="384048" cy="256032"/>
           </a:xfrm>
           <a:prstGeom prst="leftRightArrow">
             <a:avLst/>
@@ -8404,14 +8742,14 @@
       </p:sp>
       <p:sp>
         <p:nvSpPr>
-          <p:cNvPr id="17" name="Left-Right Arrow 16"/>
+          <p:cNvPr id="19" name="Left-Right Arrow 18"/>
           <p:cNvSpPr/>
           <p:nvPr/>
         </p:nvSpPr>
         <p:spPr>
           <a:xfrm>
-            <a:off x="7434072" y="2487168"/>
-            <a:ext cx="411480" cy="274320"/>
+            <a:off x="7461504" y="2423160"/>
+            <a:ext cx="384048" cy="256032"/>
           </a:xfrm>
           <a:prstGeom prst="leftRightArrow">
             <a:avLst/>
@@ -8447,7 +8785,7 @@
       </p:sp>
       <p:graphicFrame>
         <p:nvGraphicFramePr>
-          <p:cNvPr id="18" name="Table 17"/>
+          <p:cNvPr id="20" name="Table 19"/>
           <p:cNvGraphicFramePr>
             <a:graphicFrameLocks noGrp="1"/>
           </p:cNvGraphicFramePr>
@@ -9230,7 +9568,7 @@
         <p:spPr>
           <a:xfrm>
             <a:off x="841248" y="1773936"/>
-            <a:ext cx="3182112" cy="1856232"/>
+            <a:ext cx="3182112" cy="1280160"/>
           </a:xfrm>
           <a:prstGeom prst="rect">
             <a:avLst/>
@@ -9258,7 +9596,7 @@
           <a:p>
             <a:pPr>
               <a:spcBef>
-                <a:spcPts val="400"/>
+                <a:spcPts val="300"/>
               </a:spcBef>
               <a:defRPr sz="850">
                 <a:solidFill>
@@ -9274,16 +9612,67 @@
             <a:r>
               <a:t>• Thao tác: Gán IP 192.168.11.1/24 cho Server và 192.168.11.2/24 cho Client.</a:t>
             </a:r>
-            <a:br/>
-            <a:r>
-              <a:t>• Nghiệm thu: Ping 2 chiều thành công 100%, 0% loss.</a:t>
-            </a:r>
           </a:p>
         </p:txBody>
       </p:sp>
       <p:sp>
         <p:nvSpPr>
           <p:cNvPr id="10" name="Rounded Rectangle 9"/>
+          <p:cNvSpPr/>
+          <p:nvPr/>
+        </p:nvSpPr>
+        <p:spPr>
+          <a:xfrm>
+            <a:off x="841248" y="3136392"/>
+            <a:ext cx="3182112" cy="438912"/>
+          </a:xfrm>
+          <a:prstGeom prst="roundRect">
+            <a:avLst/>
+          </a:prstGeom>
+          <a:solidFill>
+            <a:srgbClr val="F0FDF4"/>
+          </a:solidFill>
+          <a:ln>
+            <a:solidFill>
+              <a:srgbClr val="BBF7D0"/>
+            </a:solidFill>
+          </a:ln>
+        </p:spPr>
+        <p:style>
+          <a:lnRef idx="1">
+            <a:schemeClr val="accent1"/>
+          </a:lnRef>
+          <a:fillRef idx="3">
+            <a:schemeClr val="accent1"/>
+          </a:fillRef>
+          <a:effectRef idx="2">
+            <a:schemeClr val="accent1"/>
+          </a:effectRef>
+          <a:fontRef idx="minor">
+            <a:schemeClr val="lt1"/>
+          </a:fontRef>
+        </p:style>
+        <p:txBody>
+          <a:bodyPr rtlCol="0" anchor="ctr" wrap="square" lIns="73152" rIns="73152"/>
+          <a:lstStyle/>
+          <a:p>
+            <a:pPr algn="ctr">
+              <a:defRPr sz="800" b="1">
+                <a:solidFill>
+                  <a:srgbClr val="16A34A"/>
+                </a:solidFill>
+                <a:latin typeface="Segoe UI"/>
+              </a:defRPr>
+            </a:pPr>
+            <a:r>
+              <a:t>[✓ NGHIỆM THU]: Ping 2 chiều thành công 100%, 0% packet loss.</a:t>
+            </a:r>
+          </a:p>
+        </p:txBody>
+      </p:sp>
+      <p:sp>
+        <p:nvSpPr>
+          <p:cNvPr id="11" name="Rounded Rectangle 10"/>
           <p:cNvSpPr/>
           <p:nvPr/>
         </p:nvSpPr>
@@ -9328,7 +9717,7 @@
       </p:sp>
       <p:sp>
         <p:nvSpPr>
-          <p:cNvPr id="11" name="Rounded Rectangle 10"/>
+          <p:cNvPr id="12" name="Rounded Rectangle 11"/>
           <p:cNvSpPr/>
           <p:nvPr/>
         </p:nvSpPr>
@@ -9381,14 +9770,14 @@
       </p:sp>
       <p:sp>
         <p:nvSpPr>
-          <p:cNvPr id="12" name="TextBox 11"/>
+          <p:cNvPr id="13" name="TextBox 12"/>
           <p:cNvSpPr txBox="1"/>
           <p:nvPr/>
         </p:nvSpPr>
         <p:spPr>
           <a:xfrm>
             <a:off x="4498848" y="1773936"/>
-            <a:ext cx="3182112" cy="1856232"/>
+            <a:ext cx="3182112" cy="1280160"/>
           </a:xfrm>
           <a:prstGeom prst="rect">
             <a:avLst/>
@@ -9416,7 +9805,7 @@
           <a:p>
             <a:pPr>
               <a:spcBef>
-                <a:spcPts val="400"/>
+                <a:spcPts val="300"/>
               </a:spcBef>
               <a:defRPr sz="850">
                 <a:solidFill>
@@ -9432,16 +9821,67 @@
             <a:r>
               <a:t>• Thao tác: Chọn Active Directory Domain Services, kèm bộ công cụ RSAT.</a:t>
             </a:r>
-            <a:br/>
-            <a:r>
-              <a:t>• Nghiệm thu: Hoàn tất cài đặt binary thành công.</a:t>
-            </a:r>
-          </a:p>
-        </p:txBody>
-      </p:sp>
-      <p:sp>
-        <p:nvSpPr>
-          <p:cNvPr id="13" name="Rounded Rectangle 12"/>
+          </a:p>
+        </p:txBody>
+      </p:sp>
+      <p:sp>
+        <p:nvSpPr>
+          <p:cNvPr id="14" name="Rounded Rectangle 13"/>
+          <p:cNvSpPr/>
+          <p:nvPr/>
+        </p:nvSpPr>
+        <p:spPr>
+          <a:xfrm>
+            <a:off x="4498848" y="3136392"/>
+            <a:ext cx="3182112" cy="438912"/>
+          </a:xfrm>
+          <a:prstGeom prst="roundRect">
+            <a:avLst/>
+          </a:prstGeom>
+          <a:solidFill>
+            <a:srgbClr val="F0FDF4"/>
+          </a:solidFill>
+          <a:ln>
+            <a:solidFill>
+              <a:srgbClr val="BBF7D0"/>
+            </a:solidFill>
+          </a:ln>
+        </p:spPr>
+        <p:style>
+          <a:lnRef idx="1">
+            <a:schemeClr val="accent1"/>
+          </a:lnRef>
+          <a:fillRef idx="3">
+            <a:schemeClr val="accent1"/>
+          </a:fillRef>
+          <a:effectRef idx="2">
+            <a:schemeClr val="accent1"/>
+          </a:effectRef>
+          <a:fontRef idx="minor">
+            <a:schemeClr val="lt1"/>
+          </a:fontRef>
+        </p:style>
+        <p:txBody>
+          <a:bodyPr rtlCol="0" anchor="ctr" wrap="square" lIns="73152" rIns="73152"/>
+          <a:lstStyle/>
+          <a:p>
+            <a:pPr algn="ctr">
+              <a:defRPr sz="800" b="1">
+                <a:solidFill>
+                  <a:srgbClr val="16A34A"/>
+                </a:solidFill>
+                <a:latin typeface="Segoe UI"/>
+              </a:defRPr>
+            </a:pPr>
+            <a:r>
+              <a:t>[✓ NGHIỆM THU]: Role AD DS &amp; RSAT báo Installation Succeeded.</a:t>
+            </a:r>
+          </a:p>
+        </p:txBody>
+      </p:sp>
+      <p:sp>
+        <p:nvSpPr>
+          <p:cNvPr id="15" name="Rounded Rectangle 14"/>
           <p:cNvSpPr/>
           <p:nvPr/>
         </p:nvSpPr>
@@ -9486,7 +9926,7 @@
       </p:sp>
       <p:sp>
         <p:nvSpPr>
-          <p:cNvPr id="14" name="Rounded Rectangle 13"/>
+          <p:cNvPr id="16" name="Rounded Rectangle 15"/>
           <p:cNvSpPr/>
           <p:nvPr/>
         </p:nvSpPr>
@@ -9539,14 +9979,14 @@
       </p:sp>
       <p:sp>
         <p:nvSpPr>
-          <p:cNvPr id="15" name="TextBox 14"/>
+          <p:cNvPr id="17" name="TextBox 16"/>
           <p:cNvSpPr txBox="1"/>
           <p:nvPr/>
         </p:nvSpPr>
         <p:spPr>
           <a:xfrm>
             <a:off x="8156448" y="1773936"/>
-            <a:ext cx="3182112" cy="1856232"/>
+            <a:ext cx="3182112" cy="1280160"/>
           </a:xfrm>
           <a:prstGeom prst="rect">
             <a:avLst/>
@@ -9574,7 +10014,7 @@
           <a:p>
             <a:pPr>
               <a:spcBef>
-                <a:spcPts val="400"/>
+                <a:spcPts val="300"/>
               </a:spcBef>
               <a:defRPr sz="850">
                 <a:solidFill>
@@ -9590,16 +10030,67 @@
             <a:r>
               <a:t>• Thao tác: 'Add a new forest', root domain 'nhom1.vn', tích hợp DNS &amp; GC.</a:t>
             </a:r>
-            <a:br/>
-            <a:r>
-              <a:t>• Nghiệm thu: Server tự khởi động lại, đăng nhập domain.</a:t>
-            </a:r>
-          </a:p>
-        </p:txBody>
-      </p:sp>
-      <p:sp>
-        <p:nvSpPr>
-          <p:cNvPr id="16" name="Rounded Rectangle 15"/>
+          </a:p>
+        </p:txBody>
+      </p:sp>
+      <p:sp>
+        <p:nvSpPr>
+          <p:cNvPr id="18" name="Rounded Rectangle 17"/>
+          <p:cNvSpPr/>
+          <p:nvPr/>
+        </p:nvSpPr>
+        <p:spPr>
+          <a:xfrm>
+            <a:off x="8156448" y="3136392"/>
+            <a:ext cx="3182112" cy="438912"/>
+          </a:xfrm>
+          <a:prstGeom prst="roundRect">
+            <a:avLst/>
+          </a:prstGeom>
+          <a:solidFill>
+            <a:srgbClr val="F0FDF4"/>
+          </a:solidFill>
+          <a:ln>
+            <a:solidFill>
+              <a:srgbClr val="BBF7D0"/>
+            </a:solidFill>
+          </a:ln>
+        </p:spPr>
+        <p:style>
+          <a:lnRef idx="1">
+            <a:schemeClr val="accent1"/>
+          </a:lnRef>
+          <a:fillRef idx="3">
+            <a:schemeClr val="accent1"/>
+          </a:fillRef>
+          <a:effectRef idx="2">
+            <a:schemeClr val="accent1"/>
+          </a:effectRef>
+          <a:fontRef idx="minor">
+            <a:schemeClr val="lt1"/>
+          </a:fontRef>
+        </p:style>
+        <p:txBody>
+          <a:bodyPr rtlCol="0" anchor="ctr" wrap="square" lIns="73152" rIns="73152"/>
+          <a:lstStyle/>
+          <a:p>
+            <a:pPr algn="ctr">
+              <a:defRPr sz="800" b="1">
+                <a:solidFill>
+                  <a:srgbClr val="16A34A"/>
+                </a:solidFill>
+                <a:latin typeface="Segoe UI"/>
+              </a:defRPr>
+            </a:pPr>
+            <a:r>
+              <a:t>[✓ NGHIỆM THU]: Thăng cấp DC thành công, tạo Forest nhom1.vn.</a:t>
+            </a:r>
+          </a:p>
+        </p:txBody>
+      </p:sp>
+      <p:sp>
+        <p:nvSpPr>
+          <p:cNvPr id="19" name="Rounded Rectangle 18"/>
           <p:cNvSpPr/>
           <p:nvPr/>
         </p:nvSpPr>
@@ -9644,7 +10135,7 @@
       </p:sp>
       <p:sp>
         <p:nvSpPr>
-          <p:cNvPr id="17" name="Rounded Rectangle 16"/>
+          <p:cNvPr id="20" name="Rounded Rectangle 19"/>
           <p:cNvSpPr/>
           <p:nvPr/>
         </p:nvSpPr>
@@ -9697,14 +10188,14 @@
       </p:sp>
       <p:sp>
         <p:nvSpPr>
-          <p:cNvPr id="18" name="TextBox 17"/>
+          <p:cNvPr id="21" name="TextBox 20"/>
           <p:cNvSpPr txBox="1"/>
           <p:nvPr/>
         </p:nvSpPr>
         <p:spPr>
           <a:xfrm>
             <a:off x="841248" y="4288536"/>
-            <a:ext cx="3182112" cy="1856232"/>
+            <a:ext cx="3182112" cy="1280160"/>
           </a:xfrm>
           <a:prstGeom prst="rect">
             <a:avLst/>
@@ -9732,7 +10223,7 @@
           <a:p>
             <a:pPr>
               <a:spcBef>
-                <a:spcPts val="400"/>
+                <a:spcPts val="300"/>
               </a:spcBef>
               <a:defRPr sz="850">
                 <a:solidFill>
@@ -9748,16 +10239,67 @@
             <a:r>
               <a:t>• Thao tác: Chạy adprep /forestprep, /domainprep /gpprep, /rodcprep.</a:t>
             </a:r>
-            <a:br/>
-            <a:r>
-              <a:t>• Nghiệm thu: Giải thích trực quan tác động kỹ thuật lên Schema.</a:t>
-            </a:r>
-          </a:p>
-        </p:txBody>
-      </p:sp>
-      <p:sp>
-        <p:nvSpPr>
-          <p:cNvPr id="19" name="Rounded Rectangle 18"/>
+          </a:p>
+        </p:txBody>
+      </p:sp>
+      <p:sp>
+        <p:nvSpPr>
+          <p:cNvPr id="22" name="Rounded Rectangle 21"/>
+          <p:cNvSpPr/>
+          <p:nvPr/>
+        </p:nvSpPr>
+        <p:spPr>
+          <a:xfrm>
+            <a:off x="841248" y="5650992"/>
+            <a:ext cx="3182112" cy="438912"/>
+          </a:xfrm>
+          <a:prstGeom prst="roundRect">
+            <a:avLst/>
+          </a:prstGeom>
+          <a:solidFill>
+            <a:srgbClr val="F0FDF4"/>
+          </a:solidFill>
+          <a:ln>
+            <a:solidFill>
+              <a:srgbClr val="BBF7D0"/>
+            </a:solidFill>
+          </a:ln>
+        </p:spPr>
+        <p:style>
+          <a:lnRef idx="1">
+            <a:schemeClr val="accent1"/>
+          </a:lnRef>
+          <a:fillRef idx="3">
+            <a:schemeClr val="accent1"/>
+          </a:fillRef>
+          <a:effectRef idx="2">
+            <a:schemeClr val="accent1"/>
+          </a:effectRef>
+          <a:fontRef idx="minor">
+            <a:schemeClr val="lt1"/>
+          </a:fontRef>
+        </p:style>
+        <p:txBody>
+          <a:bodyPr rtlCol="0" anchor="ctr" wrap="square" lIns="73152" rIns="73152"/>
+          <a:lstStyle/>
+          <a:p>
+            <a:pPr algn="ctr">
+              <a:defRPr sz="800" b="1">
+                <a:solidFill>
+                  <a:srgbClr val="16A34A"/>
+                </a:solidFill>
+                <a:latin typeface="Segoe UI"/>
+              </a:defRPr>
+            </a:pPr>
+            <a:r>
+              <a:t>[✓ NGHIỆM THU]: Chạy 3 lệnh adprep thành công không lỗi.</a:t>
+            </a:r>
+          </a:p>
+        </p:txBody>
+      </p:sp>
+      <p:sp>
+        <p:nvSpPr>
+          <p:cNvPr id="23" name="Rounded Rectangle 22"/>
           <p:cNvSpPr/>
           <p:nvPr/>
         </p:nvSpPr>
@@ -9802,7 +10344,7 @@
       </p:sp>
       <p:sp>
         <p:nvSpPr>
-          <p:cNvPr id="20" name="Rounded Rectangle 19"/>
+          <p:cNvPr id="24" name="Rounded Rectangle 23"/>
           <p:cNvSpPr/>
           <p:nvPr/>
         </p:nvSpPr>
@@ -9855,14 +10397,14 @@
       </p:sp>
       <p:sp>
         <p:nvSpPr>
-          <p:cNvPr id="21" name="TextBox 20"/>
+          <p:cNvPr id="25" name="TextBox 24"/>
           <p:cNvSpPr txBox="1"/>
           <p:nvPr/>
         </p:nvSpPr>
         <p:spPr>
           <a:xfrm>
             <a:off x="4498848" y="4288536"/>
-            <a:ext cx="3182112" cy="1856232"/>
+            <a:ext cx="3182112" cy="1280160"/>
           </a:xfrm>
           <a:prstGeom prst="rect">
             <a:avLst/>
@@ -9890,7 +10432,7 @@
           <a:p>
             <a:pPr>
               <a:spcBef>
-                <a:spcPts val="400"/>
+                <a:spcPts val="300"/>
               </a:spcBef>
               <a:defRPr sz="850">
                 <a:solidFill>
@@ -9906,16 +10448,67 @@
             <a:r>
               <a:t>• Thao tác: Tạo OU 'KHOA-CNTT', tạo User 'sv1'. Kiểm tra SYSVOL &amp; NETLOGON.</a:t>
             </a:r>
-            <a:br/>
-            <a:r>
-              <a:t>• Nghiệm thu: Hai thư mục chia sẻ hoạt động ổn định.</a:t>
-            </a:r>
-          </a:p>
-        </p:txBody>
-      </p:sp>
-      <p:sp>
-        <p:nvSpPr>
-          <p:cNvPr id="22" name="Rounded Rectangle 21"/>
+          </a:p>
+        </p:txBody>
+      </p:sp>
+      <p:sp>
+        <p:nvSpPr>
+          <p:cNvPr id="26" name="Rounded Rectangle 25"/>
+          <p:cNvSpPr/>
+          <p:nvPr/>
+        </p:nvSpPr>
+        <p:spPr>
+          <a:xfrm>
+            <a:off x="4498848" y="5650992"/>
+            <a:ext cx="3182112" cy="438912"/>
+          </a:xfrm>
+          <a:prstGeom prst="roundRect">
+            <a:avLst/>
+          </a:prstGeom>
+          <a:solidFill>
+            <a:srgbClr val="F0FDF4"/>
+          </a:solidFill>
+          <a:ln>
+            <a:solidFill>
+              <a:srgbClr val="BBF7D0"/>
+            </a:solidFill>
+          </a:ln>
+        </p:spPr>
+        <p:style>
+          <a:lnRef idx="1">
+            <a:schemeClr val="accent1"/>
+          </a:lnRef>
+          <a:fillRef idx="3">
+            <a:schemeClr val="accent1"/>
+          </a:fillRef>
+          <a:effectRef idx="2">
+            <a:schemeClr val="accent1"/>
+          </a:effectRef>
+          <a:fontRef idx="minor">
+            <a:schemeClr val="lt1"/>
+          </a:fontRef>
+        </p:style>
+        <p:txBody>
+          <a:bodyPr rtlCol="0" anchor="ctr" wrap="square" lIns="73152" rIns="73152"/>
+          <a:lstStyle/>
+          <a:p>
+            <a:pPr algn="ctr">
+              <a:defRPr sz="800" b="1">
+                <a:solidFill>
+                  <a:srgbClr val="16A34A"/>
+                </a:solidFill>
+                <a:latin typeface="Segoe UI"/>
+              </a:defRPr>
+            </a:pPr>
+            <a:r>
+              <a:t>[✓ NGHIỆM THU]: Tạo OU, User, xác nhận SYSVOL &amp; NETLOGON live.</a:t>
+            </a:r>
+          </a:p>
+        </p:txBody>
+      </p:sp>
+      <p:sp>
+        <p:nvSpPr>
+          <p:cNvPr id="27" name="Rounded Rectangle 26"/>
           <p:cNvSpPr/>
           <p:nvPr/>
         </p:nvSpPr>
@@ -9960,7 +10553,7 @@
       </p:sp>
       <p:sp>
         <p:nvSpPr>
-          <p:cNvPr id="23" name="Rounded Rectangle 22"/>
+          <p:cNvPr id="28" name="Rounded Rectangle 27"/>
           <p:cNvSpPr/>
           <p:nvPr/>
         </p:nvSpPr>
@@ -10013,14 +10606,14 @@
       </p:sp>
       <p:sp>
         <p:nvSpPr>
-          <p:cNvPr id="24" name="TextBox 23"/>
+          <p:cNvPr id="29" name="TextBox 28"/>
           <p:cNvSpPr txBox="1"/>
           <p:nvPr/>
         </p:nvSpPr>
         <p:spPr>
           <a:xfrm>
             <a:off x="8156448" y="4288536"/>
-            <a:ext cx="3182112" cy="1856232"/>
+            <a:ext cx="3182112" cy="1280160"/>
           </a:xfrm>
           <a:prstGeom prst="rect">
             <a:avLst/>
@@ -10048,7 +10641,7 @@
           <a:p>
             <a:pPr>
               <a:spcBef>
-                <a:spcPts val="400"/>
+                <a:spcPts val="300"/>
               </a:spcBef>
               <a:defRPr sz="850">
                 <a:solidFill>
@@ -10064,9 +10657,60 @@
             <a:r>
               <a:t>• Thao tác: Trỏ DNS về DC -&gt; Join domain 'nhom1.vn' -&gt; Khởi động lại máy.</a:t>
             </a:r>
-            <a:br/>
-            <a:r>
-              <a:t>• Nghiệm thu: Đăng nhập user nhom1\sv1, gõ whoami xác nhận 100%.</a:t>
+          </a:p>
+        </p:txBody>
+      </p:sp>
+      <p:sp>
+        <p:nvSpPr>
+          <p:cNvPr id="30" name="Rounded Rectangle 29"/>
+          <p:cNvSpPr/>
+          <p:nvPr/>
+        </p:nvSpPr>
+        <p:spPr>
+          <a:xfrm>
+            <a:off x="8156448" y="5650992"/>
+            <a:ext cx="3182112" cy="438912"/>
+          </a:xfrm>
+          <a:prstGeom prst="roundRect">
+            <a:avLst/>
+          </a:prstGeom>
+          <a:solidFill>
+            <a:srgbClr val="F0FDF4"/>
+          </a:solidFill>
+          <a:ln>
+            <a:solidFill>
+              <a:srgbClr val="BBF7D0"/>
+            </a:solidFill>
+          </a:ln>
+        </p:spPr>
+        <p:style>
+          <a:lnRef idx="1">
+            <a:schemeClr val="accent1"/>
+          </a:lnRef>
+          <a:fillRef idx="3">
+            <a:schemeClr val="accent1"/>
+          </a:fillRef>
+          <a:effectRef idx="2">
+            <a:schemeClr val="accent1"/>
+          </a:effectRef>
+          <a:fontRef idx="minor">
+            <a:schemeClr val="lt1"/>
+          </a:fontRef>
+        </p:style>
+        <p:txBody>
+          <a:bodyPr rtlCol="0" anchor="ctr" wrap="square" lIns="73152" rIns="73152"/>
+          <a:lstStyle/>
+          <a:p>
+            <a:pPr algn="ctr">
+              <a:defRPr sz="800" b="1">
+                <a:solidFill>
+                  <a:srgbClr val="16A34A"/>
+                </a:solidFill>
+                <a:latin typeface="Segoe UI"/>
+              </a:defRPr>
+            </a:pPr>
+            <a:r>
+              <a:t>[✓ NGHIỆM THU]: Win 7 join domain, whoami ra nhom1\sv1.</a:t>
             </a:r>
           </a:p>
         </p:txBody>
@@ -18665,7 +19309,7 @@
         <p:spPr>
           <a:xfrm>
             <a:off x="6263640" y="2304288"/>
-            <a:ext cx="2148840" cy="1737360"/>
+            <a:ext cx="2148840" cy="1280160"/>
           </a:xfrm>
           <a:prstGeom prst="rect">
             <a:avLst/>
@@ -18703,10 +19347,6 @@
             </a:r>
             <a:br/>
             <a:r>
-              <a:t>• CSDL ntds.dit đầy đủ (Đọc/Ghi)</a:t>
-            </a:r>
-            <a:br/>
-            <a:r>
               <a:t>• Băng thông LAN: 1 Gbps</a:t>
             </a:r>
           </a:p>
@@ -18714,13 +19354,68 @@
       </p:sp>
       <p:sp>
         <p:nvSpPr>
-          <p:cNvPr id="15" name="Left-Right Arrow 14"/>
+          <p:cNvPr id="15" name="Can 14"/>
           <p:cNvSpPr/>
           <p:nvPr/>
         </p:nvSpPr>
         <p:spPr>
           <a:xfrm>
-            <a:off x="8558784" y="2697480"/>
+            <a:off x="6355080" y="3639312"/>
+            <a:ext cx="1965960" cy="384048"/>
+          </a:xfrm>
+          <a:prstGeom prst="can">
+            <a:avLst/>
+          </a:prstGeom>
+          <a:solidFill>
+            <a:srgbClr val="ECFEFF"/>
+          </a:solidFill>
+          <a:ln>
+            <a:solidFill>
+              <a:srgbClr val="003366"/>
+            </a:solidFill>
+          </a:ln>
+        </p:spPr>
+        <p:style>
+          <a:lnRef idx="1">
+            <a:schemeClr val="accent1"/>
+          </a:lnRef>
+          <a:fillRef idx="3">
+            <a:schemeClr val="accent1"/>
+          </a:fillRef>
+          <a:effectRef idx="2">
+            <a:schemeClr val="accent1"/>
+          </a:effectRef>
+          <a:fontRef idx="minor">
+            <a:schemeClr val="lt1"/>
+          </a:fontRef>
+        </p:style>
+        <p:txBody>
+          <a:bodyPr rtlCol="0" anchor="ctr"/>
+          <a:lstStyle/>
+          <a:p>
+            <a:pPr algn="ctr">
+              <a:defRPr sz="800" b="1">
+                <a:solidFill>
+                  <a:srgbClr val="003366"/>
+                </a:solidFill>
+                <a:latin typeface="Segoe UI"/>
+              </a:defRPr>
+            </a:pPr>
+            <a:r>
+              <a:t>ntds.dit (Đọc/Ghi)</a:t>
+            </a:r>
+          </a:p>
+        </p:txBody>
+      </p:sp>
+      <p:sp>
+        <p:nvSpPr>
+          <p:cNvPr id="16" name="Left-Right Arrow 15"/>
+          <p:cNvSpPr/>
+          <p:nvPr/>
+        </p:nvSpPr>
+        <p:spPr>
+          <a:xfrm>
+            <a:off x="8558784" y="2606040"/>
             <a:ext cx="411480" cy="320040"/>
           </a:xfrm>
           <a:prstGeom prst="leftRightArrow">
@@ -18757,7 +19452,47 @@
       </p:sp>
       <p:sp>
         <p:nvSpPr>
-          <p:cNvPr id="16" name="Rounded Rectangle 15"/>
+          <p:cNvPr id="17" name="TextBox 16"/>
+          <p:cNvSpPr txBox="1"/>
+          <p:nvPr/>
+        </p:nvSpPr>
+        <p:spPr>
+          <a:xfrm>
+            <a:off x="8458200" y="2971800"/>
+            <a:ext cx="621792" cy="548640"/>
+          </a:xfrm>
+          <a:prstGeom prst="rect">
+            <a:avLst/>
+          </a:prstGeom>
+          <a:noFill/>
+        </p:spPr>
+        <p:txBody>
+          <a:bodyPr wrap="square" lIns="0" rIns="0" tIns="0" bIns="0">
+            <a:spAutoFit/>
+          </a:bodyPr>
+          <a:lstStyle/>
+          <a:p>
+            <a:pPr algn="ctr">
+              <a:defRPr sz="750" b="1">
+                <a:solidFill>
+                  <a:srgbClr val="D97706"/>
+                </a:solidFill>
+                <a:latin typeface="Segoe UI"/>
+              </a:defRPr>
+            </a:pPr>
+            <a:r>
+              <a:t>WAN</a:t>
+            </a:r>
+            <a:br/>
+            <a:r>
+              <a:t>RPC/IP</a:t>
+            </a:r>
+          </a:p>
+        </p:txBody>
+      </p:sp>
+      <p:sp>
+        <p:nvSpPr>
+          <p:cNvPr id="18" name="Rounded Rectangle 17"/>
           <p:cNvSpPr/>
           <p:nvPr/>
         </p:nvSpPr>
@@ -18802,7 +19537,7 @@
       </p:sp>
       <p:sp>
         <p:nvSpPr>
-          <p:cNvPr id="17" name="Rounded Rectangle 16"/>
+          <p:cNvPr id="19" name="Rounded Rectangle 18"/>
           <p:cNvSpPr/>
           <p:nvPr/>
         </p:nvSpPr>
@@ -18855,14 +19590,14 @@
       </p:sp>
       <p:sp>
         <p:nvSpPr>
-          <p:cNvPr id="18" name="TextBox 17"/>
+          <p:cNvPr id="20" name="TextBox 19"/>
           <p:cNvSpPr txBox="1"/>
           <p:nvPr/>
         </p:nvSpPr>
         <p:spPr>
           <a:xfrm>
             <a:off x="9125712" y="2304288"/>
-            <a:ext cx="2057400" cy="1737360"/>
+            <a:ext cx="2057400" cy="1280160"/>
           </a:xfrm>
           <a:prstGeom prst="rect">
             <a:avLst/>
@@ -18900,10 +19635,6 @@
             </a:r>
             <a:br/>
             <a:r>
-              <a:t>• Đồng bộ định kỳ với DC1</a:t>
-            </a:r>
-            <a:br/>
-            <a:r>
               <a:t>• Băng thông LAN: 1 Gbps</a:t>
             </a:r>
           </a:p>
@@ -18911,7 +19642,62 @@
       </p:sp>
       <p:sp>
         <p:nvSpPr>
-          <p:cNvPr id="19" name="Rounded Rectangle 18"/>
+          <p:cNvPr id="21" name="Can 20"/>
+          <p:cNvSpPr/>
+          <p:nvPr/>
+        </p:nvSpPr>
+        <p:spPr>
+          <a:xfrm>
+            <a:off x="9189720" y="3639312"/>
+            <a:ext cx="1920240" cy="384048"/>
+          </a:xfrm>
+          <a:prstGeom prst="can">
+            <a:avLst/>
+          </a:prstGeom>
+          <a:solidFill>
+            <a:srgbClr val="EFF6FF"/>
+          </a:solidFill>
+          <a:ln>
+            <a:solidFill>
+              <a:srgbClr val="0E7490"/>
+            </a:solidFill>
+          </a:ln>
+        </p:spPr>
+        <p:style>
+          <a:lnRef idx="1">
+            <a:schemeClr val="accent1"/>
+          </a:lnRef>
+          <a:fillRef idx="3">
+            <a:schemeClr val="accent1"/>
+          </a:fillRef>
+          <a:effectRef idx="2">
+            <a:schemeClr val="accent1"/>
+          </a:effectRef>
+          <a:fontRef idx="minor">
+            <a:schemeClr val="lt1"/>
+          </a:fontRef>
+        </p:style>
+        <p:txBody>
+          <a:bodyPr rtlCol="0" anchor="ctr"/>
+          <a:lstStyle/>
+          <a:p>
+            <a:pPr algn="ctr">
+              <a:defRPr sz="800" b="1">
+                <a:solidFill>
+                  <a:srgbClr val="0E7490"/>
+                </a:solidFill>
+                <a:latin typeface="Segoe UI"/>
+              </a:defRPr>
+            </a:pPr>
+            <a:r>
+              <a:t>ntds.dit (Bản sao)</a:t>
+            </a:r>
+          </a:p>
+        </p:txBody>
+      </p:sp>
+      <p:sp>
+        <p:nvSpPr>
+          <p:cNvPr id="22" name="Rounded Rectangle 21"/>
           <p:cNvSpPr/>
           <p:nvPr/>
         </p:nvSpPr>

</xml_diff>